<commit_message>
docs: update business strategy to reflect 1.5 million user growth target and adjust scaling roadmaps accordingly
</commit_message>
<xml_diff>
--- a/docs/business_strategy/east_ventures_pitch_deck.pptx
+++ b/docs/business_strategy/east_ventures_pitch_deck.pptx
@@ -3211,7 +3211,7 @@
               </a:defRPr>
             </a:pPr>
             <a:r>
-              <a:t>A modern, highly secure multi-tenant platform targeting a 1 Million Active User milestone by making enterprise-grade features affordable across all business scales.</a:t>
+              <a:t>A modern, highly secure multi-tenant platform targeting a 1.5 Million Active User milestone by making enterprise-grade features affordable across all business scales.</a:t>
             </a:r>
           </a:p>
         </p:txBody>
@@ -4242,7 +4242,7 @@
               </a:defRPr>
             </a:pPr>
             <a:r>
-              <a:t>1,000,000</a:t>
+              <a:t>1,500,000</a:t>
             </a:r>
           </a:p>
           <a:p>
@@ -4271,7 +4271,7 @@
               </a:defRPr>
             </a:pPr>
             <a:r>
-              <a:t>Achieved by capturing just ~2% of Indonesia's 50-60M formal workforce across all business sizes.</a:t>
+              <a:t>Achieved by capturing just ~3% of Indonesia's 50-60M formal workforce across all business sizes.</a:t>
             </a:r>
           </a:p>
         </p:txBody>
@@ -4369,7 +4369,7 @@
               </a:defRPr>
             </a:pPr>
             <a:r>
-              <a:t>1M Active Users Scaling Scenarios</a:t>
+              <a:t>1.5M Active Users Scaling Scenarios</a:t>
             </a:r>
           </a:p>
         </p:txBody>
@@ -4451,7 +4451,7 @@
               </a:defRPr>
             </a:pPr>
             <a:r>
-              <a:t>Blueprint baseline (Rp 3.22B MRR)</a:t>
+              <a:t>Blueprint baseline (Rp 4.83B MRR)</a:t>
             </a:r>
           </a:p>
           <a:p>
@@ -4467,7 +4467,7 @@
               </a:defRPr>
             </a:pPr>
             <a:r>
-              <a:t>Rp 3.22 Billion</a:t>
+              <a:t>Rp 4.83 Billion</a:t>
             </a:r>
           </a:p>
           <a:p>
@@ -4499,7 +4499,7 @@
               </a:defRPr>
             </a:pPr>
             <a:r>
-              <a:t>• Requires: 13,500 Tenants</a:t>
+              <a:t>• Requires: 20,250 Tenants</a:t>
             </a:r>
           </a:p>
           <a:p>
@@ -4515,7 +4515,7 @@
               </a:defRPr>
             </a:pPr>
             <a:r>
-              <a:t>• UMK (Essential): 10,000 tenants</a:t>
+              <a:t>• UMK (Essential): 15,000 tenants</a:t>
             </a:r>
           </a:p>
           <a:p>
@@ -4531,7 +4531,7 @@
               </a:defRPr>
             </a:pPr>
             <a:r>
-              <a:t>• UMM (Professional): 3,000 tenants</a:t>
+              <a:t>• UMM (Professional): 4,500 tenants</a:t>
             </a:r>
           </a:p>
           <a:p>
@@ -4547,7 +4547,7 @@
               </a:defRPr>
             </a:pPr>
             <a:r>
-              <a:t>• Enterprise (Premium): 450 tenants</a:t>
+              <a:t>• Enterprise (Premium): 675 tenants</a:t>
             </a:r>
           </a:p>
           <a:p>
@@ -4563,7 +4563,7 @@
               </a:defRPr>
             </a:pPr>
             <a:r>
-              <a:t>• Dedicated (Large): 50 tenants</a:t>
+              <a:t>• Dedicated (Large): 75 tenants</a:t>
             </a:r>
           </a:p>
           <a:p>
@@ -4677,7 +4677,7 @@
               </a:defRPr>
             </a:pPr>
             <a:r>
-              <a:t>UMK-Dominant (Rp 5.1B MRR)</a:t>
+              <a:t>UMK-Dominant (Rp 7.65B MRR)</a:t>
             </a:r>
           </a:p>
           <a:p>
@@ -4693,7 +4693,7 @@
               </a:defRPr>
             </a:pPr>
             <a:r>
-              <a:t>Rp 5.1 Billion</a:t>
+              <a:t>Rp 7.65 Billion</a:t>
             </a:r>
           </a:p>
           <a:p>
@@ -4725,7 +4725,7 @@
               </a:defRPr>
             </a:pPr>
             <a:r>
-              <a:t>• Requires: 29,360 Tenants</a:t>
+              <a:t>• Requires: 44,040 Tenants</a:t>
             </a:r>
           </a:p>
           <a:p>
@@ -4741,7 +4741,7 @@
               </a:defRPr>
             </a:pPr>
             <a:r>
-              <a:t>• UMK (Essential): 25,000 tenants</a:t>
+              <a:t>• UMK (Essential): 37,500 tenants</a:t>
             </a:r>
           </a:p>
           <a:p>
@@ -4757,7 +4757,7 @@
               </a:defRPr>
             </a:pPr>
             <a:r>
-              <a:t>• UMM (Professional): 4,000 tenants</a:t>
+              <a:t>• UMM (Professional): 6,000 tenants</a:t>
             </a:r>
           </a:p>
           <a:p>
@@ -4773,7 +4773,7 @@
               </a:defRPr>
             </a:pPr>
             <a:r>
-              <a:t>• Enterprise (Premium): 350 tenants</a:t>
+              <a:t>• Enterprise (Premium): 525 tenants</a:t>
             </a:r>
           </a:p>
           <a:p>
@@ -4789,7 +4789,7 @@
               </a:defRPr>
             </a:pPr>
             <a:r>
-              <a:t>• Dedicated (Large): 10 tenants</a:t>
+              <a:t>• Dedicated (Large): 15 tenants</a:t>
             </a:r>
           </a:p>
           <a:p>
@@ -4887,7 +4887,7 @@
               </a:defRPr>
             </a:pPr>
             <a:r>
-              <a:t>Enterprise-Dominant (Rp 3.3B MRR)</a:t>
+              <a:t>Enterprise-Dominant (Rp 4.95B MRR)</a:t>
             </a:r>
           </a:p>
           <a:p>
@@ -4903,7 +4903,7 @@
               </a:defRPr>
             </a:pPr>
             <a:r>
-              <a:t>Rp 3.3 Billion</a:t>
+              <a:t>Rp 4.95 Billion</a:t>
             </a:r>
           </a:p>
           <a:p>
@@ -4935,7 +4935,7 @@
               </a:defRPr>
             </a:pPr>
             <a:r>
-              <a:t>• Requires: 8,560 Tenants</a:t>
+              <a:t>• Requires: 12,840 Tenants</a:t>
             </a:r>
           </a:p>
           <a:p>
@@ -4951,7 +4951,7 @@
               </a:defRPr>
             </a:pPr>
             <a:r>
-              <a:t>• UMK (Essential): 5,000 tenants</a:t>
+              <a:t>• UMK (Essential): 7,500 tenants</a:t>
             </a:r>
           </a:p>
           <a:p>
@@ -4967,7 +4967,7 @@
               </a:defRPr>
             </a:pPr>
             <a:r>
-              <a:t>• UMM (Professional): 2,500 tenants</a:t>
+              <a:t>• UMM (Professional): 3,750 tenants</a:t>
             </a:r>
           </a:p>
           <a:p>
@@ -4983,7 +4983,7 @@
               </a:defRPr>
             </a:pPr>
             <a:r>
-              <a:t>• Enterprise (Premium): 1,000 tenants</a:t>
+              <a:t>• Enterprise (Premium): 1,500 tenants</a:t>
             </a:r>
           </a:p>
           <a:p>
@@ -4999,7 +4999,7 @@
               </a:defRPr>
             </a:pPr>
             <a:r>
-              <a:t>• Dedicated (Large): 60 tenants</a:t>
+              <a:t>• Dedicated (Large): 90 tenants</a:t>
             </a:r>
           </a:p>
           <a:p>

</xml_diff>